<commit_message>
Close out ATT&CK retrieval result baselines
</commit_message>
<xml_diff>
--- a/paper/portfolio_experiment_decks/EXPERIMENT_03_ATTACK_TTP_RETRIEVAL_DECK_20260514.pptx
+++ b/paper/portfolio_experiment_decks/EXPERIMENT_03_ATTACK_TTP_RETRIEVAL_DECK_20260514.pptx
@@ -12,6 +12,7 @@
     <p:sldId id="260" r:id="rId12"/>
     <p:sldId id="261" r:id="rId13"/>
     <p:sldId id="262" r:id="rId14"/>
+    <p:sldId id="263" r:id="rId15"/>
   </p:sldIdLst>
   <p:sldSz cx="12191695" cy="6858000" type="screen4x3"/>
   <p:notesSz cx="6858000" cy="9144000"/>
@@ -578,7 +579,7 @@
           <a:lstStyle/>
           <a:p>
             <a:r>
-              <a:t>The clean claim is that five observed TTPs are enough for strong candidate ranking.</a:t>
+              <a:t>The closeout claim is now stronger: retrieval beats random and frequency-prior floors while preserving the original overlap/SVD numbers.</a:t>
             </a:r>
           </a:p>
         </p:txBody>
@@ -4621,7 +4622,7 @@
               </a:defRPr>
             </a:pPr>
             <a:r>
-              <a:t>Main Result</a:t>
+              <a:t>Main Result With Floor Baselines</a:t>
             </a:r>
           </a:p>
         </p:txBody>
@@ -4690,12 +4691,13 @@
                 <a:tableStyleId>{5C22544A-7EE6-4342-B048-85BDC9FD1C3A}</a:tableStyleId>
               </a:tblPr>
               <a:tblGrid>
-                <a:gridCol w="1813560"/>
-                <a:gridCol w="1813560"/>
-                <a:gridCol w="1813560"/>
-                <a:gridCol w="1813560"/>
-                <a:gridCol w="1813560"/>
-                <a:gridCol w="1813560"/>
+                <a:gridCol w="1554480"/>
+                <a:gridCol w="1554480"/>
+                <a:gridCol w="1554480"/>
+                <a:gridCol w="1554480"/>
+                <a:gridCol w="1554480"/>
+                <a:gridCol w="1554480"/>
+                <a:gridCol w="1554480"/>
               </a:tblGrid>
               <a:tr h="822960">
                 <a:tc>
@@ -4836,6 +4838,29 @@
                     </a:solidFill>
                   </a:tcPr>
                 </a:tc>
+                <a:tc>
+                  <a:txBody>
+                    <a:bodyPr/>
+                    <a:lstStyle/>
+                    <a:p>
+                      <a:pPr>
+                        <a:defRPr sz="1500" b="1">
+                          <a:solidFill>
+                            <a:srgbClr val="111827"/>
+                          </a:solidFill>
+                        </a:defRPr>
+                      </a:pPr>
+                      <a:r>
+                        <a:t>Lift vs random</a:t>
+                      </a:r>
+                    </a:p>
+                  </a:txBody>
+                  <a:tcPr>
+                    <a:solidFill>
+                      <a:srgbClr val="DBEAFE"/>
+                    </a:solidFill>
+                  </a:tcPr>
+                </a:tc>
               </a:tr>
               <a:tr h="822960">
                 <a:tc>
@@ -4851,102 +4876,121 @@
                         </a:defRPr>
                       </a:pPr>
                       <a:r>
-                        <a:t>overlap_cosine</a:t>
-                      </a:r>
-                    </a:p>
-                  </a:txBody>
-                  <a:tcPr/>
-                </a:tc>
-                <a:tc>
-                  <a:txBody>
-                    <a:bodyPr/>
-                    <a:lstStyle/>
-                    <a:p>
-                      <a:pPr>
-                        <a:defRPr sz="1500" b="0">
-                          <a:solidFill>
-                            <a:srgbClr val="111827"/>
-                          </a:solidFill>
-                        </a:defRPr>
-                      </a:pPr>
-                      <a:r>
-                        <a:t>3</a:t>
-                      </a:r>
-                    </a:p>
-                  </a:txBody>
-                  <a:tcPr/>
-                </a:tc>
-                <a:tc>
-                  <a:txBody>
-                    <a:bodyPr/>
-                    <a:lstStyle/>
-                    <a:p>
-                      <a:pPr>
-                        <a:defRPr sz="1500" b="0">
-                          <a:solidFill>
-                            <a:srgbClr val="111827"/>
-                          </a:solidFill>
-                        </a:defRPr>
-                      </a:pPr>
-                      <a:r>
-                        <a:t>0.425</a:t>
-                      </a:r>
-                    </a:p>
-                  </a:txBody>
-                  <a:tcPr/>
-                </a:tc>
-                <a:tc>
-                  <a:txBody>
-                    <a:bodyPr/>
-                    <a:lstStyle/>
-                    <a:p>
-                      <a:pPr>
-                        <a:defRPr sz="1500" b="0">
-                          <a:solidFill>
-                            <a:srgbClr val="111827"/>
-                          </a:solidFill>
-                        </a:defRPr>
-                      </a:pPr>
-                      <a:r>
-                        <a:t>0.846</a:t>
-                      </a:r>
-                    </a:p>
-                  </a:txBody>
-                  <a:tcPr/>
-                </a:tc>
-                <a:tc>
-                  <a:txBody>
-                    <a:bodyPr/>
-                    <a:lstStyle/>
-                    <a:p>
-                      <a:pPr>
-                        <a:defRPr sz="1500" b="0">
-                          <a:solidFill>
-                            <a:srgbClr val="111827"/>
-                          </a:solidFill>
-                        </a:defRPr>
-                      </a:pPr>
-                      <a:r>
-                        <a:t>0.602</a:t>
-                      </a:r>
-                    </a:p>
-                  </a:txBody>
-                  <a:tcPr/>
-                </a:tc>
-                <a:tc>
-                  <a:txBody>
-                    <a:bodyPr/>
-                    <a:lstStyle/>
-                    <a:p>
-                      <a:pPr>
-                        <a:defRPr sz="1500" b="0">
-                          <a:solidFill>
-                            <a:srgbClr val="111827"/>
-                          </a:solidFill>
-                        </a:defRPr>
-                      </a:pPr>
-                      <a:r>
-                        <a:t>2.0</a:t>
+                        <a:t>random_uniform</a:t>
+                      </a:r>
+                    </a:p>
+                  </a:txBody>
+                  <a:tcPr/>
+                </a:tc>
+                <a:tc>
+                  <a:txBody>
+                    <a:bodyPr/>
+                    <a:lstStyle/>
+                    <a:p>
+                      <a:pPr>
+                        <a:defRPr sz="1500" b="0">
+                          <a:solidFill>
+                            <a:srgbClr val="111827"/>
+                          </a:solidFill>
+                        </a:defRPr>
+                      </a:pPr>
+                      <a:r>
+                        <a:t>5</a:t>
+                      </a:r>
+                    </a:p>
+                  </a:txBody>
+                  <a:tcPr/>
+                </a:tc>
+                <a:tc>
+                  <a:txBody>
+                    <a:bodyPr/>
+                    <a:lstStyle/>
+                    <a:p>
+                      <a:pPr>
+                        <a:defRPr sz="1500" b="0">
+                          <a:solidFill>
+                            <a:srgbClr val="111827"/>
+                          </a:solidFill>
+                        </a:defRPr>
+                      </a:pPr>
+                      <a:r>
+                        <a:t>0.005</a:t>
+                      </a:r>
+                    </a:p>
+                  </a:txBody>
+                  <a:tcPr/>
+                </a:tc>
+                <a:tc>
+                  <a:txBody>
+                    <a:bodyPr/>
+                    <a:lstStyle/>
+                    <a:p>
+                      <a:pPr>
+                        <a:defRPr sz="1500" b="0">
+                          <a:solidFill>
+                            <a:srgbClr val="111827"/>
+                          </a:solidFill>
+                        </a:defRPr>
+                      </a:pPr>
+                      <a:r>
+                        <a:t>0.028</a:t>
+                      </a:r>
+                    </a:p>
+                  </a:txBody>
+                  <a:tcPr/>
+                </a:tc>
+                <a:tc>
+                  <a:txBody>
+                    <a:bodyPr/>
+                    <a:lstStyle/>
+                    <a:p>
+                      <a:pPr>
+                        <a:defRPr sz="1500" b="0">
+                          <a:solidFill>
+                            <a:srgbClr val="111827"/>
+                          </a:solidFill>
+                        </a:defRPr>
+                      </a:pPr>
+                      <a:r>
+                        <a:t>0.033</a:t>
+                      </a:r>
+                    </a:p>
+                  </a:txBody>
+                  <a:tcPr/>
+                </a:tc>
+                <a:tc>
+                  <a:txBody>
+                    <a:bodyPr/>
+                    <a:lstStyle/>
+                    <a:p>
+                      <a:pPr>
+                        <a:defRPr sz="1500" b="0">
+                          <a:solidFill>
+                            <a:srgbClr val="111827"/>
+                          </a:solidFill>
+                        </a:defRPr>
+                      </a:pPr>
+                      <a:r>
+                        <a:t>84.0</a:t>
+                      </a:r>
+                    </a:p>
+                  </a:txBody>
+                  <a:tcPr/>
+                </a:tc>
+                <a:tc>
+                  <a:txBody>
+                    <a:bodyPr/>
+                    <a:lstStyle/>
+                    <a:p>
+                      <a:pPr>
+                        <a:defRPr sz="1500" b="0">
+                          <a:solidFill>
+                            <a:srgbClr val="111827"/>
+                          </a:solidFill>
+                        </a:defRPr>
+                      </a:pPr>
+                      <a:r>
+                        <a:t>1.0x</a:t>
                       </a:r>
                     </a:p>
                   </a:txBody>
@@ -4967,102 +5011,121 @@
                         </a:defRPr>
                       </a:pPr>
                       <a:r>
-                        <a:t>svd32_graph_embedding</a:t>
-                      </a:r>
-                    </a:p>
-                  </a:txBody>
-                  <a:tcPr/>
-                </a:tc>
-                <a:tc>
-                  <a:txBody>
-                    <a:bodyPr/>
-                    <a:lstStyle/>
-                    <a:p>
-                      <a:pPr>
-                        <a:defRPr sz="1500" b="0">
-                          <a:solidFill>
-                            <a:srgbClr val="111827"/>
-                          </a:solidFill>
-                        </a:defRPr>
-                      </a:pPr>
-                      <a:r>
-                        <a:t>3</a:t>
-                      </a:r>
-                    </a:p>
-                  </a:txBody>
-                  <a:tcPr/>
-                </a:tc>
-                <a:tc>
-                  <a:txBody>
-                    <a:bodyPr/>
-                    <a:lstStyle/>
-                    <a:p>
-                      <a:pPr>
-                        <a:defRPr sz="1500" b="0">
-                          <a:solidFill>
-                            <a:srgbClr val="111827"/>
-                          </a:solidFill>
-                        </a:defRPr>
-                      </a:pPr>
-                      <a:r>
-                        <a:t>0.306</a:t>
-                      </a:r>
-                    </a:p>
-                  </a:txBody>
-                  <a:tcPr/>
-                </a:tc>
-                <a:tc>
-                  <a:txBody>
-                    <a:bodyPr/>
-                    <a:lstStyle/>
-                    <a:p>
-                      <a:pPr>
-                        <a:defRPr sz="1500" b="0">
-                          <a:solidFill>
-                            <a:srgbClr val="111827"/>
-                          </a:solidFill>
-                        </a:defRPr>
-                      </a:pPr>
-                      <a:r>
-                        <a:t>0.684</a:t>
-                      </a:r>
-                    </a:p>
-                  </a:txBody>
-                  <a:tcPr/>
-                </a:tc>
-                <a:tc>
-                  <a:txBody>
-                    <a:bodyPr/>
-                    <a:lstStyle/>
-                    <a:p>
-                      <a:pPr>
-                        <a:defRPr sz="1500" b="0">
-                          <a:solidFill>
-                            <a:srgbClr val="111827"/>
-                          </a:solidFill>
-                        </a:defRPr>
-                      </a:pPr>
-                      <a:r>
-                        <a:t>0.479</a:t>
-                      </a:r>
-                    </a:p>
-                  </a:txBody>
-                  <a:tcPr/>
-                </a:tc>
-                <a:tc>
-                  <a:txBody>
-                    <a:bodyPr/>
-                    <a:lstStyle/>
-                    <a:p>
-                      <a:pPr>
-                        <a:defRPr sz="1500" b="0">
-                          <a:solidFill>
-                            <a:srgbClr val="111827"/>
-                          </a:solidFill>
-                        </a:defRPr>
-                      </a:pPr>
-                      <a:r>
-                        <a:t>3.0</a:t>
+                        <a:t>frequency_prior</a:t>
+                      </a:r>
+                    </a:p>
+                  </a:txBody>
+                  <a:tcPr/>
+                </a:tc>
+                <a:tc>
+                  <a:txBody>
+                    <a:bodyPr/>
+                    <a:lstStyle/>
+                    <a:p>
+                      <a:pPr>
+                        <a:defRPr sz="1500" b="0">
+                          <a:solidFill>
+                            <a:srgbClr val="111827"/>
+                          </a:solidFill>
+                        </a:defRPr>
+                      </a:pPr>
+                      <a:r>
+                        <a:t>5</a:t>
+                      </a:r>
+                    </a:p>
+                  </a:txBody>
+                  <a:tcPr/>
+                </a:tc>
+                <a:tc>
+                  <a:txBody>
+                    <a:bodyPr/>
+                    <a:lstStyle/>
+                    <a:p>
+                      <a:pPr>
+                        <a:defRPr sz="1500" b="0">
+                          <a:solidFill>
+                            <a:srgbClr val="111827"/>
+                          </a:solidFill>
+                        </a:defRPr>
+                      </a:pPr>
+                      <a:r>
+                        <a:t>0.008</a:t>
+                      </a:r>
+                    </a:p>
+                  </a:txBody>
+                  <a:tcPr/>
+                </a:tc>
+                <a:tc>
+                  <a:txBody>
+                    <a:bodyPr/>
+                    <a:lstStyle/>
+                    <a:p>
+                      <a:pPr>
+                        <a:defRPr sz="1500" b="0">
+                          <a:solidFill>
+                            <a:srgbClr val="111827"/>
+                          </a:solidFill>
+                        </a:defRPr>
+                      </a:pPr>
+                      <a:r>
+                        <a:t>0.041</a:t>
+                      </a:r>
+                    </a:p>
+                  </a:txBody>
+                  <a:tcPr/>
+                </a:tc>
+                <a:tc>
+                  <a:txBody>
+                    <a:bodyPr/>
+                    <a:lstStyle/>
+                    <a:p>
+                      <a:pPr>
+                        <a:defRPr sz="1500" b="0">
+                          <a:solidFill>
+                            <a:srgbClr val="111827"/>
+                          </a:solidFill>
+                        </a:defRPr>
+                      </a:pPr>
+                      <a:r>
+                        <a:t>0.044</a:t>
+                      </a:r>
+                    </a:p>
+                  </a:txBody>
+                  <a:tcPr/>
+                </a:tc>
+                <a:tc>
+                  <a:txBody>
+                    <a:bodyPr/>
+                    <a:lstStyle/>
+                    <a:p>
+                      <a:pPr>
+                        <a:defRPr sz="1500" b="0">
+                          <a:solidFill>
+                            <a:srgbClr val="111827"/>
+                          </a:solidFill>
+                        </a:defRPr>
+                      </a:pPr>
+                      <a:r>
+                        <a:t>61.0</a:t>
+                      </a:r>
+                    </a:p>
+                  </a:txBody>
+                  <a:tcPr/>
+                </a:tc>
+                <a:tc>
+                  <a:txBody>
+                    <a:bodyPr/>
+                    <a:lstStyle/>
+                    <a:p>
+                      <a:pPr>
+                        <a:defRPr sz="1500" b="0">
+                          <a:solidFill>
+                            <a:srgbClr val="111827"/>
+                          </a:solidFill>
+                        </a:defRPr>
+                      </a:pPr>
+                      <a:r>
+                        <a:t>1.5x</a:t>
                       </a:r>
                     </a:p>
                   </a:txBody>
@@ -5184,6 +5247,25 @@
                   </a:txBody>
                   <a:tcPr/>
                 </a:tc>
+                <a:tc>
+                  <a:txBody>
+                    <a:bodyPr/>
+                    <a:lstStyle/>
+                    <a:p>
+                      <a:pPr>
+                        <a:defRPr sz="1500" b="0">
+                          <a:solidFill>
+                            <a:srgbClr val="111827"/>
+                          </a:solidFill>
+                        </a:defRPr>
+                      </a:pPr>
+                      <a:r>
+                        <a:t>34.2x</a:t>
+                      </a:r>
+                    </a:p>
+                  </a:txBody>
+                  <a:tcPr/>
+                </a:tc>
               </a:tr>
               <a:tr h="822960">
                 <a:tc>
@@ -5295,6 +5377,25 @@
                       </a:pPr>
                       <a:r>
                         <a:t>1.0</a:t>
+                      </a:r>
+                    </a:p>
+                  </a:txBody>
+                  <a:tcPr/>
+                </a:tc>
+                <a:tc>
+                  <a:txBody>
+                    <a:bodyPr/>
+                    <a:lstStyle/>
+                    <a:p>
+                      <a:pPr>
+                        <a:defRPr sz="1500" b="0">
+                          <a:solidFill>
+                            <a:srgbClr val="111827"/>
+                          </a:solidFill>
+                        </a:defRPr>
+                      </a:pPr>
+                      <a:r>
+                        <a:t>31.3x</a:t>
                       </a:r>
                     </a:p>
                   </a:txBody>
@@ -5353,7 +5454,7 @@
               </a:defRPr>
             </a:pPr>
             <a:r>
-              <a:t>Negative GNN Gate</a:t>
+              <a:t>Degree-Bucket Check</a:t>
             </a:r>
           </a:p>
         </p:txBody>
@@ -5428,7 +5529,7 @@
                 <a:gridCol w="2176272"/>
                 <a:gridCol w="2176272"/>
               </a:tblGrid>
-              <a:tr h="822960">
+              <a:tr h="587828">
                 <a:tc>
                   <a:txBody>
                     <a:bodyPr/>
@@ -5442,7 +5543,7 @@
                         </a:defRPr>
                       </a:pPr>
                       <a:r>
-                        <a:t>Mode</a:t>
+                        <a:t>Method</a:t>
                       </a:r>
                     </a:p>
                   </a:txBody>
@@ -5465,7 +5566,7 @@
                         </a:defRPr>
                       </a:pPr>
                       <a:r>
-                        <a:t>Method</a:t>
+                        <a:t>Bucket</a:t>
                       </a:r>
                     </a:p>
                   </a:txBody>
@@ -5488,7 +5589,7 @@
                         </a:defRPr>
                       </a:pPr>
                       <a:r>
-                        <a:t>Shots</a:t>
+                        <a:t>Top-5</a:t>
                       </a:r>
                     </a:p>
                   </a:txBody>
@@ -5511,7 +5612,7 @@
                         </a:defRPr>
                       </a:pPr>
                       <a:r>
-                        <a:t>Top-5</a:t>
+                        <a:t>MRR</a:t>
                       </a:r>
                     </a:p>
                   </a:txBody>
@@ -5545,78 +5646,78 @@
                   </a:tcPr>
                 </a:tc>
               </a:tr>
-              <a:tr h="822960">
-                <a:tc>
-                  <a:txBody>
-                    <a:bodyPr/>
-                    <a:lstStyle/>
-                    <a:p>
-                      <a:pPr>
-                        <a:defRPr sz="1500" b="0">
-                          <a:solidFill>
-                            <a:srgbClr val="111827"/>
-                          </a:solidFill>
-                        </a:defRPr>
-                      </a:pPr>
-                      <a:r>
-                        <a:t>known_profile</a:t>
-                      </a:r>
-                    </a:p>
-                  </a:txBody>
-                  <a:tcPr/>
-                </a:tc>
-                <a:tc>
-                  <a:txBody>
-                    <a:bodyPr/>
-                    <a:lstStyle/>
-                    <a:p>
-                      <a:pPr>
-                        <a:defRPr sz="1500" b="0">
-                          <a:solidFill>
-                            <a:srgbClr val="111827"/>
-                          </a:solidFill>
-                        </a:defRPr>
-                      </a:pPr>
-                      <a:r>
-                        <a:t>overlap_cosine_train</a:t>
-                      </a:r>
-                    </a:p>
-                  </a:txBody>
-                  <a:tcPr/>
-                </a:tc>
-                <a:tc>
-                  <a:txBody>
-                    <a:bodyPr/>
-                    <a:lstStyle/>
-                    <a:p>
-                      <a:pPr>
-                        <a:defRPr sz="1500" b="0">
-                          <a:solidFill>
-                            <a:srgbClr val="111827"/>
-                          </a:solidFill>
-                        </a:defRPr>
-                      </a:pPr>
-                      <a:r>
-                        <a:t>5</a:t>
-                      </a:r>
-                    </a:p>
-                  </a:txBody>
-                  <a:tcPr/>
-                </a:tc>
-                <a:tc>
-                  <a:txBody>
-                    <a:bodyPr/>
-                    <a:lstStyle/>
-                    <a:p>
-                      <a:pPr>
-                        <a:defRPr sz="1500" b="0">
-                          <a:solidFill>
-                            <a:srgbClr val="111827"/>
-                          </a:solidFill>
-                        </a:defRPr>
-                      </a:pPr>
-                      <a:r>
-                        <a:t>0.985</a:t>
+              <a:tr h="587828">
+                <a:tc>
+                  <a:txBody>
+                    <a:bodyPr/>
+                    <a:lstStyle/>
+                    <a:p>
+                      <a:pPr>
+                        <a:defRPr sz="1500" b="0">
+                          <a:solidFill>
+                            <a:srgbClr val="111827"/>
+                          </a:solidFill>
+                        </a:defRPr>
+                      </a:pPr>
+                      <a:r>
+                        <a:t>overlap_cosine</a:t>
+                      </a:r>
+                    </a:p>
+                  </a:txBody>
+                  <a:tcPr/>
+                </a:tc>
+                <a:tc>
+                  <a:txBody>
+                    <a:bodyPr/>
+                    <a:lstStyle/>
+                    <a:p>
+                      <a:pPr>
+                        <a:defRPr sz="1500" b="0">
+                          <a:solidFill>
+                            <a:srgbClr val="111827"/>
+                          </a:solidFill>
+                        </a:defRPr>
+                      </a:pPr>
+                      <a:r>
+                        <a:t>low</a:t>
+                      </a:r>
+                    </a:p>
+                  </a:txBody>
+                  <a:tcPr/>
+                </a:tc>
+                <a:tc>
+                  <a:txBody>
+                    <a:bodyPr/>
+                    <a:lstStyle/>
+                    <a:p>
+                      <a:pPr>
+                        <a:defRPr sz="1500" b="0">
+                          <a:solidFill>
+                            <a:srgbClr val="111827"/>
+                          </a:solidFill>
+                        </a:defRPr>
+                      </a:pPr>
+                      <a:r>
+                        <a:t>0.995</a:t>
+                      </a:r>
+                    </a:p>
+                  </a:txBody>
+                  <a:tcPr/>
+                </a:tc>
+                <a:tc>
+                  <a:txBody>
+                    <a:bodyPr/>
+                    <a:lstStyle/>
+                    <a:p>
+                      <a:pPr>
+                        <a:defRPr sz="1500" b="0">
+                          <a:solidFill>
+                            <a:srgbClr val="111827"/>
+                          </a:solidFill>
+                        </a:defRPr>
+                      </a:pPr>
+                      <a:r>
+                        <a:t>0.953</a:t>
                       </a:r>
                     </a:p>
                   </a:txBody>
@@ -5642,78 +5743,78 @@
                   <a:tcPr/>
                 </a:tc>
               </a:tr>
-              <a:tr h="822960">
-                <a:tc>
-                  <a:txBody>
-                    <a:bodyPr/>
-                    <a:lstStyle/>
-                    <a:p>
-                      <a:pPr>
-                        <a:defRPr sz="1500" b="0">
-                          <a:solidFill>
-                            <a:srgbClr val="111827"/>
-                          </a:solidFill>
-                        </a:defRPr>
-                      </a:pPr>
-                      <a:r>
-                        <a:t>known_profile</a:t>
-                      </a:r>
-                    </a:p>
-                  </a:txBody>
-                  <a:tcPr/>
-                </a:tc>
-                <a:tc>
-                  <a:txBody>
-                    <a:bodyPr/>
-                    <a:lstStyle/>
-                    <a:p>
-                      <a:pPr>
-                        <a:defRPr sz="1500" b="0">
-                          <a:solidFill>
-                            <a:srgbClr val="111827"/>
-                          </a:solidFill>
-                        </a:defRPr>
-                      </a:pPr>
-                      <a:r>
-                        <a:t>svd32_train_graph</a:t>
-                      </a:r>
-                    </a:p>
-                  </a:txBody>
-                  <a:tcPr/>
-                </a:tc>
-                <a:tc>
-                  <a:txBody>
-                    <a:bodyPr/>
-                    <a:lstStyle/>
-                    <a:p>
-                      <a:pPr>
-                        <a:defRPr sz="1500" b="0">
-                          <a:solidFill>
-                            <a:srgbClr val="111827"/>
-                          </a:solidFill>
-                        </a:defRPr>
-                      </a:pPr>
-                      <a:r>
-                        <a:t>5</a:t>
-                      </a:r>
-                    </a:p>
-                  </a:txBody>
-                  <a:tcPr/>
-                </a:tc>
-                <a:tc>
-                  <a:txBody>
-                    <a:bodyPr/>
-                    <a:lstStyle/>
-                    <a:p>
-                      <a:pPr>
-                        <a:defRPr sz="1500" b="0">
-                          <a:solidFill>
-                            <a:srgbClr val="111827"/>
-                          </a:solidFill>
-                        </a:defRPr>
-                      </a:pPr>
-                      <a:r>
-                        <a:t>0.926</a:t>
+              <a:tr h="587828">
+                <a:tc>
+                  <a:txBody>
+                    <a:bodyPr/>
+                    <a:lstStyle/>
+                    <a:p>
+                      <a:pPr>
+                        <a:defRPr sz="1500" b="0">
+                          <a:solidFill>
+                            <a:srgbClr val="111827"/>
+                          </a:solidFill>
+                        </a:defRPr>
+                      </a:pPr>
+                      <a:r>
+                        <a:t>overlap_cosine</a:t>
+                      </a:r>
+                    </a:p>
+                  </a:txBody>
+                  <a:tcPr/>
+                </a:tc>
+                <a:tc>
+                  <a:txBody>
+                    <a:bodyPr/>
+                    <a:lstStyle/>
+                    <a:p>
+                      <a:pPr>
+                        <a:defRPr sz="1500" b="0">
+                          <a:solidFill>
+                            <a:srgbClr val="111827"/>
+                          </a:solidFill>
+                        </a:defRPr>
+                      </a:pPr>
+                      <a:r>
+                        <a:t>mid</a:t>
+                      </a:r>
+                    </a:p>
+                  </a:txBody>
+                  <a:tcPr/>
+                </a:tc>
+                <a:tc>
+                  <a:txBody>
+                    <a:bodyPr/>
+                    <a:lstStyle/>
+                    <a:p>
+                      <a:pPr>
+                        <a:defRPr sz="1500" b="0">
+                          <a:solidFill>
+                            <a:srgbClr val="111827"/>
+                          </a:solidFill>
+                        </a:defRPr>
+                      </a:pPr>
+                      <a:r>
+                        <a:t>0.995</a:t>
+                      </a:r>
+                    </a:p>
+                  </a:txBody>
+                  <a:tcPr/>
+                </a:tc>
+                <a:tc>
+                  <a:txBody>
+                    <a:bodyPr/>
+                    <a:lstStyle/>
+                    <a:p>
+                      <a:pPr>
+                        <a:defRPr sz="1500" b="0">
+                          <a:solidFill>
+                            <a:srgbClr val="111827"/>
+                          </a:solidFill>
+                        </a:defRPr>
+                      </a:pPr>
+                      <a:r>
+                        <a:t>0.866</a:t>
                       </a:r>
                     </a:p>
                   </a:txBody>
@@ -5739,194 +5840,388 @@
                   <a:tcPr/>
                 </a:tc>
               </a:tr>
-              <a:tr h="822960">
-                <a:tc>
-                  <a:txBody>
-                    <a:bodyPr/>
-                    <a:lstStyle/>
-                    <a:p>
-                      <a:pPr>
-                        <a:defRPr sz="1500" b="0">
-                          <a:solidFill>
-                            <a:srgbClr val="111827"/>
-                          </a:solidFill>
-                        </a:defRPr>
-                      </a:pPr>
-                      <a:r>
-                        <a:t>known_profile</a:t>
-                      </a:r>
-                    </a:p>
-                  </a:txBody>
-                  <a:tcPr/>
-                </a:tc>
-                <a:tc>
-                  <a:txBody>
-                    <a:bodyPr/>
-                    <a:lstStyle/>
-                    <a:p>
-                      <a:pPr>
-                        <a:defRPr sz="1500" b="0">
-                          <a:solidFill>
-                            <a:srgbClr val="111827"/>
-                          </a:solidFill>
-                        </a:defRPr>
-                      </a:pPr>
-                      <a:r>
-                        <a:t>graphsage_linkpred</a:t>
-                      </a:r>
-                    </a:p>
-                  </a:txBody>
-                  <a:tcPr/>
-                </a:tc>
-                <a:tc>
-                  <a:txBody>
-                    <a:bodyPr/>
-                    <a:lstStyle/>
-                    <a:p>
-                      <a:pPr>
-                        <a:defRPr sz="1500" b="0">
-                          <a:solidFill>
-                            <a:srgbClr val="111827"/>
-                          </a:solidFill>
-                        </a:defRPr>
-                      </a:pPr>
-                      <a:r>
-                        <a:t>5</a:t>
-                      </a:r>
-                    </a:p>
-                  </a:txBody>
-                  <a:tcPr/>
-                </a:tc>
-                <a:tc>
-                  <a:txBody>
-                    <a:bodyPr/>
-                    <a:lstStyle/>
-                    <a:p>
-                      <a:pPr>
-                        <a:defRPr sz="1500" b="0">
-                          <a:solidFill>
-                            <a:srgbClr val="111827"/>
-                          </a:solidFill>
-                        </a:defRPr>
-                      </a:pPr>
-                      <a:r>
-                        <a:t>0.060</a:t>
-                      </a:r>
-                    </a:p>
-                  </a:txBody>
-                  <a:tcPr/>
-                </a:tc>
-                <a:tc>
-                  <a:txBody>
-                    <a:bodyPr/>
-                    <a:lstStyle/>
-                    <a:p>
-                      <a:pPr>
-                        <a:defRPr sz="1500" b="0">
-                          <a:solidFill>
-                            <a:srgbClr val="111827"/>
-                          </a:solidFill>
-                        </a:defRPr>
-                      </a:pPr>
-                      <a:r>
-                        <a:t>60.0</a:t>
+              <a:tr h="587828">
+                <a:tc>
+                  <a:txBody>
+                    <a:bodyPr/>
+                    <a:lstStyle/>
+                    <a:p>
+                      <a:pPr>
+                        <a:defRPr sz="1500" b="0">
+                          <a:solidFill>
+                            <a:srgbClr val="111827"/>
+                          </a:solidFill>
+                        </a:defRPr>
+                      </a:pPr>
+                      <a:r>
+                        <a:t>overlap_cosine</a:t>
+                      </a:r>
+                    </a:p>
+                  </a:txBody>
+                  <a:tcPr/>
+                </a:tc>
+                <a:tc>
+                  <a:txBody>
+                    <a:bodyPr/>
+                    <a:lstStyle/>
+                    <a:p>
+                      <a:pPr>
+                        <a:defRPr sz="1500" b="0">
+                          <a:solidFill>
+                            <a:srgbClr val="111827"/>
+                          </a:solidFill>
+                        </a:defRPr>
+                      </a:pPr>
+                      <a:r>
+                        <a:t>high</a:t>
+                      </a:r>
+                    </a:p>
+                  </a:txBody>
+                  <a:tcPr/>
+                </a:tc>
+                <a:tc>
+                  <a:txBody>
+                    <a:bodyPr/>
+                    <a:lstStyle/>
+                    <a:p>
+                      <a:pPr>
+                        <a:defRPr sz="1500" b="0">
+                          <a:solidFill>
+                            <a:srgbClr val="111827"/>
+                          </a:solidFill>
+                        </a:defRPr>
+                      </a:pPr>
+                      <a:r>
+                        <a:t>0.887</a:t>
+                      </a:r>
+                    </a:p>
+                  </a:txBody>
+                  <a:tcPr/>
+                </a:tc>
+                <a:tc>
+                  <a:txBody>
+                    <a:bodyPr/>
+                    <a:lstStyle/>
+                    <a:p>
+                      <a:pPr>
+                        <a:defRPr sz="1500" b="0">
+                          <a:solidFill>
+                            <a:srgbClr val="111827"/>
+                          </a:solidFill>
+                        </a:defRPr>
+                      </a:pPr>
+                      <a:r>
+                        <a:t>0.644</a:t>
+                      </a:r>
+                    </a:p>
+                  </a:txBody>
+                  <a:tcPr/>
+                </a:tc>
+                <a:tc>
+                  <a:txBody>
+                    <a:bodyPr/>
+                    <a:lstStyle/>
+                    <a:p>
+                      <a:pPr>
+                        <a:defRPr sz="1500" b="0">
+                          <a:solidFill>
+                            <a:srgbClr val="111827"/>
+                          </a:solidFill>
+                        </a:defRPr>
+                      </a:pPr>
+                      <a:r>
+                        <a:t>2.0</a:t>
                       </a:r>
                     </a:p>
                   </a:txBody>
                   <a:tcPr/>
                 </a:tc>
               </a:tr>
-              <a:tr h="822960">
-                <a:tc>
-                  <a:txBody>
-                    <a:bodyPr/>
-                    <a:lstStyle/>
-                    <a:p>
-                      <a:pPr>
-                        <a:defRPr sz="1500" b="0">
-                          <a:solidFill>
-                            <a:srgbClr val="111827"/>
-                          </a:solidFill>
-                        </a:defRPr>
-                      </a:pPr>
-                      <a:r>
-                        <a:t>held_edge</a:t>
-                      </a:r>
-                    </a:p>
-                  </a:txBody>
-                  <a:tcPr/>
-                </a:tc>
-                <a:tc>
-                  <a:txBody>
-                    <a:bodyPr/>
-                    <a:lstStyle/>
-                    <a:p>
-                      <a:pPr>
-                        <a:defRPr sz="1500" b="0">
-                          <a:solidFill>
-                            <a:srgbClr val="111827"/>
-                          </a:solidFill>
-                        </a:defRPr>
-                      </a:pPr>
-                      <a:r>
-                        <a:t>graphsage_linkpred</a:t>
-                      </a:r>
-                    </a:p>
-                  </a:txBody>
-                  <a:tcPr/>
-                </a:tc>
-                <a:tc>
-                  <a:txBody>
-                    <a:bodyPr/>
-                    <a:lstStyle/>
-                    <a:p>
-                      <a:pPr>
-                        <a:defRPr sz="1500" b="0">
-                          <a:solidFill>
-                            <a:srgbClr val="111827"/>
-                          </a:solidFill>
-                        </a:defRPr>
-                      </a:pPr>
-                      <a:r>
-                        <a:t>5</a:t>
-                      </a:r>
-                    </a:p>
-                  </a:txBody>
-                  <a:tcPr/>
-                </a:tc>
-                <a:tc>
-                  <a:txBody>
-                    <a:bodyPr/>
-                    <a:lstStyle/>
-                    <a:p>
-                      <a:pPr>
-                        <a:defRPr sz="1500" b="0">
-                          <a:solidFill>
-                            <a:srgbClr val="111827"/>
-                          </a:solidFill>
-                        </a:defRPr>
-                      </a:pPr>
-                      <a:r>
-                        <a:t>0.073</a:t>
-                      </a:r>
-                    </a:p>
-                  </a:txBody>
-                  <a:tcPr/>
-                </a:tc>
-                <a:tc>
-                  <a:txBody>
-                    <a:bodyPr/>
-                    <a:lstStyle/>
-                    <a:p>
-                      <a:pPr>
-                        <a:defRPr sz="1500" b="0">
-                          <a:solidFill>
-                            <a:srgbClr val="111827"/>
-                          </a:solidFill>
-                        </a:defRPr>
-                      </a:pPr>
-                      <a:r>
-                        <a:t>34.0</a:t>
+              <a:tr h="587828">
+                <a:tc>
+                  <a:txBody>
+                    <a:bodyPr/>
+                    <a:lstStyle/>
+                    <a:p>
+                      <a:pPr>
+                        <a:defRPr sz="1500" b="0">
+                          <a:solidFill>
+                            <a:srgbClr val="111827"/>
+                          </a:solidFill>
+                        </a:defRPr>
+                      </a:pPr>
+                      <a:r>
+                        <a:t>svd32_graph_embedding</a:t>
+                      </a:r>
+                    </a:p>
+                  </a:txBody>
+                  <a:tcPr/>
+                </a:tc>
+                <a:tc>
+                  <a:txBody>
+                    <a:bodyPr/>
+                    <a:lstStyle/>
+                    <a:p>
+                      <a:pPr>
+                        <a:defRPr sz="1500" b="0">
+                          <a:solidFill>
+                            <a:srgbClr val="111827"/>
+                          </a:solidFill>
+                        </a:defRPr>
+                      </a:pPr>
+                      <a:r>
+                        <a:t>low</a:t>
+                      </a:r>
+                    </a:p>
+                  </a:txBody>
+                  <a:tcPr/>
+                </a:tc>
+                <a:tc>
+                  <a:txBody>
+                    <a:bodyPr/>
+                    <a:lstStyle/>
+                    <a:p>
+                      <a:pPr>
+                        <a:defRPr sz="1500" b="0">
+                          <a:solidFill>
+                            <a:srgbClr val="111827"/>
+                          </a:solidFill>
+                        </a:defRPr>
+                      </a:pPr>
+                      <a:r>
+                        <a:t>0.951</a:t>
+                      </a:r>
+                    </a:p>
+                  </a:txBody>
+                  <a:tcPr/>
+                </a:tc>
+                <a:tc>
+                  <a:txBody>
+                    <a:bodyPr/>
+                    <a:lstStyle/>
+                    <a:p>
+                      <a:pPr>
+                        <a:defRPr sz="1500" b="0">
+                          <a:solidFill>
+                            <a:srgbClr val="111827"/>
+                          </a:solidFill>
+                        </a:defRPr>
+                      </a:pPr>
+                      <a:r>
+                        <a:t>0.866</a:t>
+                      </a:r>
+                    </a:p>
+                  </a:txBody>
+                  <a:tcPr/>
+                </a:tc>
+                <a:tc>
+                  <a:txBody>
+                    <a:bodyPr/>
+                    <a:lstStyle/>
+                    <a:p>
+                      <a:pPr>
+                        <a:defRPr sz="1500" b="0">
+                          <a:solidFill>
+                            <a:srgbClr val="111827"/>
+                          </a:solidFill>
+                        </a:defRPr>
+                      </a:pPr>
+                      <a:r>
+                        <a:t>1.0</a:t>
+                      </a:r>
+                    </a:p>
+                  </a:txBody>
+                  <a:tcPr/>
+                </a:tc>
+              </a:tr>
+              <a:tr h="587828">
+                <a:tc>
+                  <a:txBody>
+                    <a:bodyPr/>
+                    <a:lstStyle/>
+                    <a:p>
+                      <a:pPr>
+                        <a:defRPr sz="1500" b="0">
+                          <a:solidFill>
+                            <a:srgbClr val="111827"/>
+                          </a:solidFill>
+                        </a:defRPr>
+                      </a:pPr>
+                      <a:r>
+                        <a:t>svd32_graph_embedding</a:t>
+                      </a:r>
+                    </a:p>
+                  </a:txBody>
+                  <a:tcPr/>
+                </a:tc>
+                <a:tc>
+                  <a:txBody>
+                    <a:bodyPr/>
+                    <a:lstStyle/>
+                    <a:p>
+                      <a:pPr>
+                        <a:defRPr sz="1500" b="0">
+                          <a:solidFill>
+                            <a:srgbClr val="111827"/>
+                          </a:solidFill>
+                        </a:defRPr>
+                      </a:pPr>
+                      <a:r>
+                        <a:t>mid</a:t>
+                      </a:r>
+                    </a:p>
+                  </a:txBody>
+                  <a:tcPr/>
+                </a:tc>
+                <a:tc>
+                  <a:txBody>
+                    <a:bodyPr/>
+                    <a:lstStyle/>
+                    <a:p>
+                      <a:pPr>
+                        <a:defRPr sz="1500" b="0">
+                          <a:solidFill>
+                            <a:srgbClr val="111827"/>
+                          </a:solidFill>
+                        </a:defRPr>
+                      </a:pPr>
+                      <a:r>
+                        <a:t>0.854</a:t>
+                      </a:r>
+                    </a:p>
+                  </a:txBody>
+                  <a:tcPr/>
+                </a:tc>
+                <a:tc>
+                  <a:txBody>
+                    <a:bodyPr/>
+                    <a:lstStyle/>
+                    <a:p>
+                      <a:pPr>
+                        <a:defRPr sz="1500" b="0">
+                          <a:solidFill>
+                            <a:srgbClr val="111827"/>
+                          </a:solidFill>
+                        </a:defRPr>
+                      </a:pPr>
+                      <a:r>
+                        <a:t>0.667</a:t>
+                      </a:r>
+                    </a:p>
+                  </a:txBody>
+                  <a:tcPr/>
+                </a:tc>
+                <a:tc>
+                  <a:txBody>
+                    <a:bodyPr/>
+                    <a:lstStyle/>
+                    <a:p>
+                      <a:pPr>
+                        <a:defRPr sz="1500" b="0">
+                          <a:solidFill>
+                            <a:srgbClr val="111827"/>
+                          </a:solidFill>
+                        </a:defRPr>
+                      </a:pPr>
+                      <a:r>
+                        <a:t>1.0</a:t>
+                      </a:r>
+                    </a:p>
+                  </a:txBody>
+                  <a:tcPr/>
+                </a:tc>
+              </a:tr>
+              <a:tr h="587832">
+                <a:tc>
+                  <a:txBody>
+                    <a:bodyPr/>
+                    <a:lstStyle/>
+                    <a:p>
+                      <a:pPr>
+                        <a:defRPr sz="1500" b="0">
+                          <a:solidFill>
+                            <a:srgbClr val="111827"/>
+                          </a:solidFill>
+                        </a:defRPr>
+                      </a:pPr>
+                      <a:r>
+                        <a:t>svd32_graph_embedding</a:t>
+                      </a:r>
+                    </a:p>
+                  </a:txBody>
+                  <a:tcPr/>
+                </a:tc>
+                <a:tc>
+                  <a:txBody>
+                    <a:bodyPr/>
+                    <a:lstStyle/>
+                    <a:p>
+                      <a:pPr>
+                        <a:defRPr sz="1500" b="0">
+                          <a:solidFill>
+                            <a:srgbClr val="111827"/>
+                          </a:solidFill>
+                        </a:defRPr>
+                      </a:pPr>
+                      <a:r>
+                        <a:t>high</a:t>
+                      </a:r>
+                    </a:p>
+                  </a:txBody>
+                  <a:tcPr/>
+                </a:tc>
+                <a:tc>
+                  <a:txBody>
+                    <a:bodyPr/>
+                    <a:lstStyle/>
+                    <a:p>
+                      <a:pPr>
+                        <a:defRPr sz="1500" b="0">
+                          <a:solidFill>
+                            <a:srgbClr val="111827"/>
+                          </a:solidFill>
+                        </a:defRPr>
+                      </a:pPr>
+                      <a:r>
+                        <a:t>0.831</a:t>
+                      </a:r>
+                    </a:p>
+                  </a:txBody>
+                  <a:tcPr/>
+                </a:tc>
+                <a:tc>
+                  <a:txBody>
+                    <a:bodyPr/>
+                    <a:lstStyle/>
+                    <a:p>
+                      <a:pPr>
+                        <a:defRPr sz="1500" b="0">
+                          <a:solidFill>
+                            <a:srgbClr val="111827"/>
+                          </a:solidFill>
+                        </a:defRPr>
+                      </a:pPr>
+                      <a:r>
+                        <a:t>0.659</a:t>
+                      </a:r>
+                    </a:p>
+                  </a:txBody>
+                  <a:tcPr/>
+                </a:tc>
+                <a:tc>
+                  <a:txBody>
+                    <a:bodyPr/>
+                    <a:lstStyle/>
+                    <a:p>
+                      <a:pPr>
+                        <a:defRPr sz="1500" b="0">
+                          <a:solidFill>
+                            <a:srgbClr val="111827"/>
+                          </a:solidFill>
+                        </a:defRPr>
+                      </a:pPr>
+                      <a:r>
+                        <a:t>1.0</a:t>
                       </a:r>
                     </a:p>
                   </a:txBody>
@@ -5985,7 +6280,7 @@
               </a:defRPr>
             </a:pPr>
             <a:r>
-              <a:t>Allowed Claims</a:t>
+              <a:t>Negative GNN Gate</a:t>
             </a:r>
           </a:p>
         </p:txBody>
@@ -6035,6 +6330,638 @@
           </a:p>
         </p:txBody>
       </p:sp>
+      <p:graphicFrame>
+        <p:nvGraphicFramePr>
+          <p:cNvPr id="4" name="Table 3"/>
+          <p:cNvGraphicFramePr>
+            <a:graphicFrameLocks noGrp="1"/>
+          </p:cNvGraphicFramePr>
+          <p:nvPr/>
+        </p:nvGraphicFramePr>
+        <p:xfrm>
+          <a:off x="685800" y="1417320"/>
+          <a:ext cx="10881360" cy="4114800"/>
+        </p:xfrm>
+        <a:graphic>
+          <a:graphicData uri="http://schemas.openxmlformats.org/drawingml/2006/table">
+            <a:tbl>
+              <a:tblPr firstRow="1" bandRow="1">
+                <a:tableStyleId>{5C22544A-7EE6-4342-B048-85BDC9FD1C3A}</a:tableStyleId>
+              </a:tblPr>
+              <a:tblGrid>
+                <a:gridCol w="2176272"/>
+                <a:gridCol w="2176272"/>
+                <a:gridCol w="2176272"/>
+                <a:gridCol w="2176272"/>
+                <a:gridCol w="2176272"/>
+              </a:tblGrid>
+              <a:tr h="822960">
+                <a:tc>
+                  <a:txBody>
+                    <a:bodyPr/>
+                    <a:lstStyle/>
+                    <a:p>
+                      <a:pPr>
+                        <a:defRPr sz="1500" b="1">
+                          <a:solidFill>
+                            <a:srgbClr val="111827"/>
+                          </a:solidFill>
+                        </a:defRPr>
+                      </a:pPr>
+                      <a:r>
+                        <a:t>Mode</a:t>
+                      </a:r>
+                    </a:p>
+                  </a:txBody>
+                  <a:tcPr>
+                    <a:solidFill>
+                      <a:srgbClr val="DBEAFE"/>
+                    </a:solidFill>
+                  </a:tcPr>
+                </a:tc>
+                <a:tc>
+                  <a:txBody>
+                    <a:bodyPr/>
+                    <a:lstStyle/>
+                    <a:p>
+                      <a:pPr>
+                        <a:defRPr sz="1500" b="1">
+                          <a:solidFill>
+                            <a:srgbClr val="111827"/>
+                          </a:solidFill>
+                        </a:defRPr>
+                      </a:pPr>
+                      <a:r>
+                        <a:t>Method</a:t>
+                      </a:r>
+                    </a:p>
+                  </a:txBody>
+                  <a:tcPr>
+                    <a:solidFill>
+                      <a:srgbClr val="DBEAFE"/>
+                    </a:solidFill>
+                  </a:tcPr>
+                </a:tc>
+                <a:tc>
+                  <a:txBody>
+                    <a:bodyPr/>
+                    <a:lstStyle/>
+                    <a:p>
+                      <a:pPr>
+                        <a:defRPr sz="1500" b="1">
+                          <a:solidFill>
+                            <a:srgbClr val="111827"/>
+                          </a:solidFill>
+                        </a:defRPr>
+                      </a:pPr>
+                      <a:r>
+                        <a:t>Shots</a:t>
+                      </a:r>
+                    </a:p>
+                  </a:txBody>
+                  <a:tcPr>
+                    <a:solidFill>
+                      <a:srgbClr val="DBEAFE"/>
+                    </a:solidFill>
+                  </a:tcPr>
+                </a:tc>
+                <a:tc>
+                  <a:txBody>
+                    <a:bodyPr/>
+                    <a:lstStyle/>
+                    <a:p>
+                      <a:pPr>
+                        <a:defRPr sz="1500" b="1">
+                          <a:solidFill>
+                            <a:srgbClr val="111827"/>
+                          </a:solidFill>
+                        </a:defRPr>
+                      </a:pPr>
+                      <a:r>
+                        <a:t>Top-5</a:t>
+                      </a:r>
+                    </a:p>
+                  </a:txBody>
+                  <a:tcPr>
+                    <a:solidFill>
+                      <a:srgbClr val="DBEAFE"/>
+                    </a:solidFill>
+                  </a:tcPr>
+                </a:tc>
+                <a:tc>
+                  <a:txBody>
+                    <a:bodyPr/>
+                    <a:lstStyle/>
+                    <a:p>
+                      <a:pPr>
+                        <a:defRPr sz="1500" b="1">
+                          <a:solidFill>
+                            <a:srgbClr val="111827"/>
+                          </a:solidFill>
+                        </a:defRPr>
+                      </a:pPr>
+                      <a:r>
+                        <a:t>Median rank</a:t>
+                      </a:r>
+                    </a:p>
+                  </a:txBody>
+                  <a:tcPr>
+                    <a:solidFill>
+                      <a:srgbClr val="DBEAFE"/>
+                    </a:solidFill>
+                  </a:tcPr>
+                </a:tc>
+              </a:tr>
+              <a:tr h="822960">
+                <a:tc>
+                  <a:txBody>
+                    <a:bodyPr/>
+                    <a:lstStyle/>
+                    <a:p>
+                      <a:pPr>
+                        <a:defRPr sz="1500" b="0">
+                          <a:solidFill>
+                            <a:srgbClr val="111827"/>
+                          </a:solidFill>
+                        </a:defRPr>
+                      </a:pPr>
+                      <a:r>
+                        <a:t>known_profile</a:t>
+                      </a:r>
+                    </a:p>
+                  </a:txBody>
+                  <a:tcPr/>
+                </a:tc>
+                <a:tc>
+                  <a:txBody>
+                    <a:bodyPr/>
+                    <a:lstStyle/>
+                    <a:p>
+                      <a:pPr>
+                        <a:defRPr sz="1500" b="0">
+                          <a:solidFill>
+                            <a:srgbClr val="111827"/>
+                          </a:solidFill>
+                        </a:defRPr>
+                      </a:pPr>
+                      <a:r>
+                        <a:t>overlap_cosine_train</a:t>
+                      </a:r>
+                    </a:p>
+                  </a:txBody>
+                  <a:tcPr/>
+                </a:tc>
+                <a:tc>
+                  <a:txBody>
+                    <a:bodyPr/>
+                    <a:lstStyle/>
+                    <a:p>
+                      <a:pPr>
+                        <a:defRPr sz="1500" b="0">
+                          <a:solidFill>
+                            <a:srgbClr val="111827"/>
+                          </a:solidFill>
+                        </a:defRPr>
+                      </a:pPr>
+                      <a:r>
+                        <a:t>5</a:t>
+                      </a:r>
+                    </a:p>
+                  </a:txBody>
+                  <a:tcPr/>
+                </a:tc>
+                <a:tc>
+                  <a:txBody>
+                    <a:bodyPr/>
+                    <a:lstStyle/>
+                    <a:p>
+                      <a:pPr>
+                        <a:defRPr sz="1500" b="0">
+                          <a:solidFill>
+                            <a:srgbClr val="111827"/>
+                          </a:solidFill>
+                        </a:defRPr>
+                      </a:pPr>
+                      <a:r>
+                        <a:t>0.985</a:t>
+                      </a:r>
+                    </a:p>
+                  </a:txBody>
+                  <a:tcPr/>
+                </a:tc>
+                <a:tc>
+                  <a:txBody>
+                    <a:bodyPr/>
+                    <a:lstStyle/>
+                    <a:p>
+                      <a:pPr>
+                        <a:defRPr sz="1500" b="0">
+                          <a:solidFill>
+                            <a:srgbClr val="111827"/>
+                          </a:solidFill>
+                        </a:defRPr>
+                      </a:pPr>
+                      <a:r>
+                        <a:t>1.0</a:t>
+                      </a:r>
+                    </a:p>
+                  </a:txBody>
+                  <a:tcPr/>
+                </a:tc>
+              </a:tr>
+              <a:tr h="822960">
+                <a:tc>
+                  <a:txBody>
+                    <a:bodyPr/>
+                    <a:lstStyle/>
+                    <a:p>
+                      <a:pPr>
+                        <a:defRPr sz="1500" b="0">
+                          <a:solidFill>
+                            <a:srgbClr val="111827"/>
+                          </a:solidFill>
+                        </a:defRPr>
+                      </a:pPr>
+                      <a:r>
+                        <a:t>known_profile</a:t>
+                      </a:r>
+                    </a:p>
+                  </a:txBody>
+                  <a:tcPr/>
+                </a:tc>
+                <a:tc>
+                  <a:txBody>
+                    <a:bodyPr/>
+                    <a:lstStyle/>
+                    <a:p>
+                      <a:pPr>
+                        <a:defRPr sz="1500" b="0">
+                          <a:solidFill>
+                            <a:srgbClr val="111827"/>
+                          </a:solidFill>
+                        </a:defRPr>
+                      </a:pPr>
+                      <a:r>
+                        <a:t>svd32_train_graph</a:t>
+                      </a:r>
+                    </a:p>
+                  </a:txBody>
+                  <a:tcPr/>
+                </a:tc>
+                <a:tc>
+                  <a:txBody>
+                    <a:bodyPr/>
+                    <a:lstStyle/>
+                    <a:p>
+                      <a:pPr>
+                        <a:defRPr sz="1500" b="0">
+                          <a:solidFill>
+                            <a:srgbClr val="111827"/>
+                          </a:solidFill>
+                        </a:defRPr>
+                      </a:pPr>
+                      <a:r>
+                        <a:t>5</a:t>
+                      </a:r>
+                    </a:p>
+                  </a:txBody>
+                  <a:tcPr/>
+                </a:tc>
+                <a:tc>
+                  <a:txBody>
+                    <a:bodyPr/>
+                    <a:lstStyle/>
+                    <a:p>
+                      <a:pPr>
+                        <a:defRPr sz="1500" b="0">
+                          <a:solidFill>
+                            <a:srgbClr val="111827"/>
+                          </a:solidFill>
+                        </a:defRPr>
+                      </a:pPr>
+                      <a:r>
+                        <a:t>0.926</a:t>
+                      </a:r>
+                    </a:p>
+                  </a:txBody>
+                  <a:tcPr/>
+                </a:tc>
+                <a:tc>
+                  <a:txBody>
+                    <a:bodyPr/>
+                    <a:lstStyle/>
+                    <a:p>
+                      <a:pPr>
+                        <a:defRPr sz="1500" b="0">
+                          <a:solidFill>
+                            <a:srgbClr val="111827"/>
+                          </a:solidFill>
+                        </a:defRPr>
+                      </a:pPr>
+                      <a:r>
+                        <a:t>1.0</a:t>
+                      </a:r>
+                    </a:p>
+                  </a:txBody>
+                  <a:tcPr/>
+                </a:tc>
+              </a:tr>
+              <a:tr h="822960">
+                <a:tc>
+                  <a:txBody>
+                    <a:bodyPr/>
+                    <a:lstStyle/>
+                    <a:p>
+                      <a:pPr>
+                        <a:defRPr sz="1500" b="0">
+                          <a:solidFill>
+                            <a:srgbClr val="111827"/>
+                          </a:solidFill>
+                        </a:defRPr>
+                      </a:pPr>
+                      <a:r>
+                        <a:t>known_profile</a:t>
+                      </a:r>
+                    </a:p>
+                  </a:txBody>
+                  <a:tcPr/>
+                </a:tc>
+                <a:tc>
+                  <a:txBody>
+                    <a:bodyPr/>
+                    <a:lstStyle/>
+                    <a:p>
+                      <a:pPr>
+                        <a:defRPr sz="1500" b="0">
+                          <a:solidFill>
+                            <a:srgbClr val="111827"/>
+                          </a:solidFill>
+                        </a:defRPr>
+                      </a:pPr>
+                      <a:r>
+                        <a:t>graphsage_linkpred</a:t>
+                      </a:r>
+                    </a:p>
+                  </a:txBody>
+                  <a:tcPr/>
+                </a:tc>
+                <a:tc>
+                  <a:txBody>
+                    <a:bodyPr/>
+                    <a:lstStyle/>
+                    <a:p>
+                      <a:pPr>
+                        <a:defRPr sz="1500" b="0">
+                          <a:solidFill>
+                            <a:srgbClr val="111827"/>
+                          </a:solidFill>
+                        </a:defRPr>
+                      </a:pPr>
+                      <a:r>
+                        <a:t>5</a:t>
+                      </a:r>
+                    </a:p>
+                  </a:txBody>
+                  <a:tcPr/>
+                </a:tc>
+                <a:tc>
+                  <a:txBody>
+                    <a:bodyPr/>
+                    <a:lstStyle/>
+                    <a:p>
+                      <a:pPr>
+                        <a:defRPr sz="1500" b="0">
+                          <a:solidFill>
+                            <a:srgbClr val="111827"/>
+                          </a:solidFill>
+                        </a:defRPr>
+                      </a:pPr>
+                      <a:r>
+                        <a:t>0.060</a:t>
+                      </a:r>
+                    </a:p>
+                  </a:txBody>
+                  <a:tcPr/>
+                </a:tc>
+                <a:tc>
+                  <a:txBody>
+                    <a:bodyPr/>
+                    <a:lstStyle/>
+                    <a:p>
+                      <a:pPr>
+                        <a:defRPr sz="1500" b="0">
+                          <a:solidFill>
+                            <a:srgbClr val="111827"/>
+                          </a:solidFill>
+                        </a:defRPr>
+                      </a:pPr>
+                      <a:r>
+                        <a:t>60.0</a:t>
+                      </a:r>
+                    </a:p>
+                  </a:txBody>
+                  <a:tcPr/>
+                </a:tc>
+              </a:tr>
+              <a:tr h="822960">
+                <a:tc>
+                  <a:txBody>
+                    <a:bodyPr/>
+                    <a:lstStyle/>
+                    <a:p>
+                      <a:pPr>
+                        <a:defRPr sz="1500" b="0">
+                          <a:solidFill>
+                            <a:srgbClr val="111827"/>
+                          </a:solidFill>
+                        </a:defRPr>
+                      </a:pPr>
+                      <a:r>
+                        <a:t>held_edge</a:t>
+                      </a:r>
+                    </a:p>
+                  </a:txBody>
+                  <a:tcPr/>
+                </a:tc>
+                <a:tc>
+                  <a:txBody>
+                    <a:bodyPr/>
+                    <a:lstStyle/>
+                    <a:p>
+                      <a:pPr>
+                        <a:defRPr sz="1500" b="0">
+                          <a:solidFill>
+                            <a:srgbClr val="111827"/>
+                          </a:solidFill>
+                        </a:defRPr>
+                      </a:pPr>
+                      <a:r>
+                        <a:t>graphsage_linkpred</a:t>
+                      </a:r>
+                    </a:p>
+                  </a:txBody>
+                  <a:tcPr/>
+                </a:tc>
+                <a:tc>
+                  <a:txBody>
+                    <a:bodyPr/>
+                    <a:lstStyle/>
+                    <a:p>
+                      <a:pPr>
+                        <a:defRPr sz="1500" b="0">
+                          <a:solidFill>
+                            <a:srgbClr val="111827"/>
+                          </a:solidFill>
+                        </a:defRPr>
+                      </a:pPr>
+                      <a:r>
+                        <a:t>5</a:t>
+                      </a:r>
+                    </a:p>
+                  </a:txBody>
+                  <a:tcPr/>
+                </a:tc>
+                <a:tc>
+                  <a:txBody>
+                    <a:bodyPr/>
+                    <a:lstStyle/>
+                    <a:p>
+                      <a:pPr>
+                        <a:defRPr sz="1500" b="0">
+                          <a:solidFill>
+                            <a:srgbClr val="111827"/>
+                          </a:solidFill>
+                        </a:defRPr>
+                      </a:pPr>
+                      <a:r>
+                        <a:t>0.073</a:t>
+                      </a:r>
+                    </a:p>
+                  </a:txBody>
+                  <a:tcPr/>
+                </a:tc>
+                <a:tc>
+                  <a:txBody>
+                    <a:bodyPr/>
+                    <a:lstStyle/>
+                    <a:p>
+                      <a:pPr>
+                        <a:defRPr sz="1500" b="0">
+                          <a:solidFill>
+                            <a:srgbClr val="111827"/>
+                          </a:solidFill>
+                        </a:defRPr>
+                      </a:pPr>
+                      <a:r>
+                        <a:t>34.0</a:t>
+                      </a:r>
+                    </a:p>
+                  </a:txBody>
+                  <a:tcPr/>
+                </a:tc>
+              </a:tr>
+            </a:tbl>
+          </a:graphicData>
+        </a:graphic>
+      </p:graphicFrame>
+    </p:spTree>
+  </p:cSld>
+  <p:clrMapOvr>
+    <a:masterClrMapping/>
+  </p:clrMapOvr>
+</p:sld>
+</file>
+
+<file path=ppt/slides/slide7.xml><?xml version="1.0" encoding="utf-8"?>
+<p:sld xmlns:a="http://schemas.openxmlformats.org/drawingml/2006/main" xmlns:p="http://schemas.openxmlformats.org/presentationml/2006/main" xmlns:r="http://schemas.openxmlformats.org/officeDocument/2006/relationships">
+  <p:cSld>
+    <p:spTree>
+      <p:nvGrpSpPr>
+        <p:cNvPr id="1" name=""/>
+        <p:cNvGrpSpPr/>
+        <p:nvPr/>
+      </p:nvGrpSpPr>
+      <p:grpSpPr/>
+      <p:sp>
+        <p:nvSpPr>
+          <p:cNvPr id="2" name="TextBox 1"/>
+          <p:cNvSpPr txBox="1"/>
+          <p:nvPr/>
+        </p:nvSpPr>
+        <p:spPr>
+          <a:xfrm>
+            <a:off x="502920" y="292608"/>
+            <a:ext cx="11201400" cy="548640"/>
+          </a:xfrm>
+          <a:prstGeom prst="rect">
+            <a:avLst/>
+          </a:prstGeom>
+          <a:noFill/>
+        </p:spPr>
+        <p:txBody>
+          <a:bodyPr wrap="square">
+            <a:spAutoFit/>
+          </a:bodyPr>
+          <a:lstStyle/>
+          <a:p>
+            <a:pPr>
+              <a:defRPr sz="2800" b="1">
+                <a:solidFill>
+                  <a:srgbClr val="111827"/>
+                </a:solidFill>
+              </a:defRPr>
+            </a:pPr>
+            <a:r>
+              <a:t>Allowed Claims</a:t>
+            </a:r>
+          </a:p>
+        </p:txBody>
+      </p:sp>
+      <p:sp>
+        <p:nvSpPr>
+          <p:cNvPr id="3" name="Rectangle 2"/>
+          <p:cNvSpPr/>
+          <p:nvPr/>
+        </p:nvSpPr>
+        <p:spPr>
+          <a:xfrm>
+            <a:off x="502920" y="932688"/>
+            <a:ext cx="11109960" cy="32004"/>
+          </a:xfrm>
+          <a:prstGeom prst="rect">
+            <a:avLst/>
+          </a:prstGeom>
+          <a:solidFill>
+            <a:srgbClr val="2563EB"/>
+          </a:solidFill>
+          <a:ln>
+            <a:solidFill>
+              <a:srgbClr val="2563EB"/>
+            </a:solidFill>
+          </a:ln>
+        </p:spPr>
+        <p:style>
+          <a:lnRef idx="1">
+            <a:schemeClr val="accent1"/>
+          </a:lnRef>
+          <a:fillRef idx="3">
+            <a:schemeClr val="accent1"/>
+          </a:fillRef>
+          <a:effectRef idx="2">
+            <a:schemeClr val="accent1"/>
+          </a:effectRef>
+          <a:fontRef idx="minor">
+            <a:schemeClr val="lt1"/>
+          </a:fontRef>
+        </p:style>
+        <p:txBody>
+          <a:bodyPr rtlCol="0" anchor="ctr"/>
+          <a:lstStyle/>
+          <a:p>
+            <a:pPr algn="ctr"/>
+          </a:p>
+        </p:txBody>
+      </p:sp>
       <p:sp>
         <p:nvSpPr>
           <p:cNvPr id="4" name="TextBox 3"/>
@@ -6114,7 +7041,7 @@
 </p:sld>
 </file>
 
-<file path=ppt/slides/slide7.xml><?xml version="1.0" encoding="utf-8"?>
+<file path=ppt/slides/slide8.xml><?xml version="1.0" encoding="utf-8"?>
 <p:sld xmlns:a="http://schemas.openxmlformats.org/drawingml/2006/main" xmlns:p="http://schemas.openxmlformats.org/presentationml/2006/main" xmlns:r="http://schemas.openxmlformats.org/officeDocument/2006/relationships">
   <p:cSld>
     <p:spTree>

</xml_diff>